<commit_message>
Rewrite Day 1 speaker notes as scannable bullet lists
Every T.notes() call for Day 1 (71 total) was a single dense sentence.
Rewrote each as a bullet-list array (4-8 bullets per slide) covering:
- Framing / one-liner opening
- Key facts to say
- Audience prompts / questions to ask
- Warnings / gotchas
- Time budget hints where relevant

Notes now render as bulleted lists in Presenter View — quick to scan
mid-slide rather than dense paragraphs.

- Updated theme.js: T.notes() now accepts either string (single line) or
  array (auto-formatted as bullet list joined with newlines)
- 71/71 notes rewritten across modules 1-7
- Regenerated all seven decks

Co-authored-by: Copilot <223556219+Copilot@users.noreply.github.com>
</commit_message>
<xml_diff>
--- a/decks/day1/module-1-landscape.pptx
+++ b/decks/day1/module-1-landscape.pptx
@@ -512,7 +512,11 @@
           <a:p>
             <a:r>
               <a:rPr lang="en-US" dirty="0"/>
-              <a:t>Set the stage. Attendees include senior devs and architects who need a compass before hands-on. Emphasize this is decision-first, code-later.</a:t>
+              <a:t>• Say: this module is a compass, not code
+• Audience: senior devs + solution architects — respect their experience
+• Set expectation: decisions first, code starts Module 4
+• Time: 25 min total — keep it moving
+• Nothing in this module needs a demo</a:t>
             </a:r>
             <a:endParaRPr lang="en-US" dirty="0"/>
           </a:p>
@@ -600,7 +604,12 @@
           <a:p>
             <a:r>
               <a:rPr lang="en-US" dirty="0"/>
-              <a:t>Preview the arc. Mention every day builds on the same 'docs assistant' reference project.</a:t>
+              <a:t>• Preview the 5-day arc in 60 seconds
+• Days 1–3 build on the same 'docs assistant' reference project
+• Day 4 turns the single agent into a multi-agent workflow
+• Day 5 covers production + capstone kickoff
+• Every day maps to the four-layer stack (Module 5)
+• Post-workshop: capstone project reviewed 1:1</a:t>
             </a:r>
             <a:endParaRPr lang="en-US" dirty="0"/>
           </a:p>
@@ -776,7 +785,11 @@
           <a:p>
             <a:r>
               <a:rPr lang="en-US" dirty="0"/>
-              <a:t>This slide is the frame. Reassure that this module is short (25 min) and light on code. Set expectation: decisions today, code Module 4+.</a:t>
+              <a:t>• Frame the whole module in one sentence: 'before you write a line of code, decide which surface to build on'
+• Reassure: this module is short (25 min), light on code
+• Ask: who's already been sold on a specific approach?
+• If hands go up, promise you'll cover fit vs. their situation
+• Move quickly — the payoff slides come next</a:t>
             </a:r>
             <a:endParaRPr lang="en-US" dirty="0"/>
           </a:p>
@@ -864,7 +877,13 @@
           <a:p>
             <a:r>
               <a:rPr lang="en-US" dirty="0"/>
-              <a:t>Copilot Studio and Foundry can be complementary. This workshop = Foundry + MAF. Make it explicit: 'if your target audience is makers, this is not your workshop.'</a:t>
+              <a:t>• The three surfaces are complementary, not competitive
+• Copilot Studio → makers, business analysts, M365 destinations
+• Foundry → developer platform on Azure
+• MAF → the SDK your code uses on top of Foundry
+• Be explicit: 'if your target audience is makers, this is not your workshop'
+• Do not disparage Copilot Studio — it's the right tool for a different job
+• Publix has both audiences; this workshop targets the developer audience</a:t>
             </a:r>
             <a:endParaRPr lang="en-US" dirty="0"/>
           </a:p>
@@ -952,7 +971,12 @@
           <a:p>
             <a:r>
               <a:rPr lang="en-US" dirty="0"/>
-              <a:t>Anchor slide. Emphasize that the problem shape is the same across all three; the layer of abstraction is what shifts. Sets up the next slide's spectrum framing.</a:t>
+              <a:t>• Anchor slide — the payoff for the whole module
+• Every agent needs three things: Model, Instructions, Tools
+• That's true whether you're in Copilot Studio, Foundry, or writing raw MAF code
+• What changes across surfaces: how much code you write, who owns the runtime
+• Sets up the next slide's IaaS/PaaS/SaaS spectrum
+• Pause for questions here — this is where the mental model clicks or doesn't</a:t>
             </a:r>
             <a:endParaRPr lang="en-US" dirty="0"/>
           </a:p>
@@ -1040,7 +1064,13 @@
           <a:p>
             <a:r>
               <a:rPr lang="en-US" dirty="0"/>
-              <a:t>Use the familiar IaaS/PaaS/SaaS trio — attendees already know it. This replaces a bullet list and lands harder. Emphasize 'this workshop = PaaS.'</a:t>
+              <a:t>• Piggyback on vocabulary attendees already know
+• IaaS = OSS frameworks + containers you run
+• PaaS = Foundry Agent Service + MAF (this workshop)
+• SaaS = Copilot Studio
+• Say clearly: 'this workshop lives in PaaS territory'
+• PaaS = you write real code, you don't run the infrastructure
+• This slide replaces a bullet list — the visual lands harder, let it breathe</a:t>
             </a:r>
             <a:endParaRPr lang="en-US" dirty="0"/>
           </a:p>
@@ -1128,7 +1158,14 @@
           <a:p>
             <a:r>
               <a:rPr lang="en-US" dirty="0"/>
-              <a:t>This slide prevents the anti-pattern of building an agent for what should be a plain LLM call. Ask attendees which pattern their current use case actually needs.</a:t>
+              <a:t>• Prevents the #1 anti-pattern: 'everything must be an agent'
+• Match complexity to need — not every LLM problem needs orchestration
+• Direct LLM call: summarize this doc — cheap, easy to eval
+• Single agent w/ tools: iterative work that needs to *do* something
+• Multi-agent workflow: distinct roles, hand-offs — costly, new failure modes
+• Rule: reach for the leftmost pattern that solves the problem
+• Ask 2–3 attendees: 'what pattern does your current use case actually need?'
+• This connects directly to Day 4 (multi-agent) — plant the flag</a:t>
             </a:r>
             <a:endParaRPr lang="en-US" dirty="0"/>
           </a:p>
@@ -1216,7 +1253,13 @@
           <a:p>
             <a:r>
               <a:rPr lang="en-US" dirty="0"/>
-              <a:t>Preview only. Prompt agents, Hosted agents, Toolbox, and Foundry IQ each get their own module or day. Don't dive into any of them here.</a:t>
+              <a:t>• Preview only — resist the urge to teach any of these
+• Prompt agents / Hosted agents → Module 6 today
+• Toolbox → Day 2 (Actions layer)
+• Foundry IQ → Day 2 (Knowledge layer)
+• Responses API → Module 6 today, deeper in Days 2–3
+• Evaluators / tracing → Day 4 and Day 5
+• This slide's job: land the vocabulary once so nothing feels new later</a:t>
             </a:r>
             <a:endParaRPr lang="en-US" dirty="0"/>
           </a:p>
@@ -1304,7 +1347,13 @@
           <a:p>
             <a:r>
               <a:rPr lang="en-US" dirty="0"/>
-              <a:t>Emphasize 'one vocabulary' — attendees coming from SK / AutoGen will spot the lineage. Call SK 'still supported, not the forward path.' Don't disparage.</a:t>
+              <a:t>• One vocabulary is the key selling point of MAF
+• Same primitives (agent, thread, tool, run) in Python and C#
+• For attendees coming from SK or AutoGen: acknowledge the lineage
+• Say: 'SK is still supported, not the forward path for new work'
+• Say: 'AutoGen was the research predecessor to MAF'
+• Don't disparage — attendees have shipped code with both
+• MAF absorbed the lessons; the surface is cleaner</a:t>
             </a:r>
             <a:endParaRPr lang="en-US" dirty="0"/>
           </a:p>
@@ -1392,7 +1441,12 @@
           <a:p>
             <a:r>
               <a:rPr lang="en-US" dirty="0"/>
-              <a:t>This is important framing. Attendees with adjacent expectations need to know we're not going there today.</a:t>
+              <a:t>• Set explicit expectations about scope
+• If someone came expecting Copilot Studio depth: not this workshop
+• If someone came expecting fine-tuning or model training: not this workshop
+• Copilot Studio, SK, AutoGen, LangChain, CrewAI — all out of scope
+• Explain why: MAF is the forward direction for Publix code
+• Redirect anyone who needs the excluded topics to appropriate resources</a:t>
             </a:r>
             <a:endParaRPr lang="en-US" dirty="0"/>
           </a:p>

</xml_diff>